<commit_message>
docs: refresh README and deck assets for 62 native integrations
Update docs, pricing, screenshots, and PPT scripts to reflect the full integrations catalog and current SaaS plans.

Co-authored-by: Cursor <cursoragent@cursor.com>
</commit_message>
<xml_diff>
--- a/project/exports/Nexus_LinkedIn_Launch.pptx
+++ b/project/exports/Nexus_LinkedIn_Launch.pptx
@@ -8,6 +8,7 @@
     <p:sldId id="256" r:id="rId7"/>
     <p:sldId id="257" r:id="rId8"/>
     <p:sldId id="258" r:id="rId9"/>
+    <p:sldId id="259" r:id="rId10"/>
   </p:sldIdLst>
   <p:sldSz cx="12191695" cy="6858000" type="screen4x3"/>
   <p:notesSz cx="6858000" cy="9144000"/>
@@ -3206,6 +3207,48 @@
 </p:sld>
 </file>
 
+<file path=ppt/slides/slide4.xml><?xml version="1.0" encoding="utf-8"?>
+<p:sld xmlns:a="http://schemas.openxmlformats.org/drawingml/2006/main" xmlns:p="http://schemas.openxmlformats.org/presentationml/2006/main" xmlns:r="http://schemas.openxmlformats.org/officeDocument/2006/relationships">
+  <p:cSld>
+    <p:spTree>
+      <p:nvGrpSpPr>
+        <p:cNvPr id="1" name=""/>
+        <p:cNvGrpSpPr/>
+        <p:nvPr/>
+      </p:nvGrpSpPr>
+      <p:grpSpPr/>
+      <p:pic>
+        <p:nvPicPr>
+          <p:cNvPr id="2" name="Picture 1" descr="04-integrations.png"/>
+          <p:cNvPicPr>
+            <a:picLocks noChangeAspect="1"/>
+          </p:cNvPicPr>
+          <p:nvPr/>
+        </p:nvPicPr>
+        <p:blipFill>
+          <a:blip r:embed="rId2"/>
+          <a:stretch>
+            <a:fillRect/>
+          </a:stretch>
+        </p:blipFill>
+        <p:spPr>
+          <a:xfrm>
+            <a:off x="0" y="0"/>
+            <a:ext cx="12191695" cy="6858000"/>
+          </a:xfrm>
+          <a:prstGeom prst="rect">
+            <a:avLst/>
+          </a:prstGeom>
+        </p:spPr>
+      </p:pic>
+    </p:spTree>
+  </p:cSld>
+  <p:clrMapOvr>
+    <a:masterClrMapping/>
+  </p:clrMapOvr>
+</p:sld>
+</file>
+
 <file path=ppt/theme/theme1.xml><?xml version="1.0" encoding="utf-8"?>
 <a:theme xmlns:a="http://schemas.openxmlformats.org/drawingml/2006/main" name="Office Theme">
   <a:themeElements>

</xml_diff>

<commit_message>
chore: regenerate PPTs with 2x res and correct aspect ratio
</commit_message>
<xml_diff>
--- a/project/exports/Nexus_LinkedIn_Launch.pptx
+++ b/project/exports/Nexus_LinkedIn_Launch.pptx
@@ -3107,8 +3107,8 @@
         </p:blipFill>
         <p:spPr>
           <a:xfrm>
-            <a:off x="0" y="0"/>
-            <a:ext cx="12191695" cy="6858000"/>
+            <a:off x="609447" y="0"/>
+            <a:ext cx="10972800" cy="6858000"/>
           </a:xfrm>
           <a:prstGeom prst="rect">
             <a:avLst/>
@@ -3149,8 +3149,8 @@
         </p:blipFill>
         <p:spPr>
           <a:xfrm>
-            <a:off x="0" y="0"/>
-            <a:ext cx="12191695" cy="6858000"/>
+            <a:off x="609447" y="0"/>
+            <a:ext cx="10972800" cy="6858000"/>
           </a:xfrm>
           <a:prstGeom prst="rect">
             <a:avLst/>
@@ -3191,8 +3191,8 @@
         </p:blipFill>
         <p:spPr>
           <a:xfrm>
-            <a:off x="0" y="0"/>
-            <a:ext cx="12191695" cy="6858000"/>
+            <a:off x="609447" y="0"/>
+            <a:ext cx="10972800" cy="6858000"/>
           </a:xfrm>
           <a:prstGeom prst="rect">
             <a:avLst/>
@@ -3233,8 +3233,8 @@
         </p:blipFill>
         <p:spPr>
           <a:xfrm>
-            <a:off x="0" y="0"/>
-            <a:ext cx="12191695" cy="6858000"/>
+            <a:off x="4234649" y="0"/>
+            <a:ext cx="3722397" cy="6858000"/>
           </a:xfrm>
           <a:prstGeom prst="rect">
             <a:avLst/>

</xml_diff>